<commit_message>
edit  - Presentations.md changed
</commit_message>
<xml_diff>
--- a/docs/Presentations/assets/2026-01-29/2026.01.29.pptx
+++ b/docs/Presentations/assets/2026-01-29/2026.01.29.pptx
@@ -153,6 +153,14 @@
     </p:ext>
   </p:extLst>
 </p:presentation>
+</file>
+
+<file path=ppt/revisionInfo.xml><?xml version="1.0" encoding="utf-8"?>
+<p1510:revInfo xmlns:a="http://schemas.openxmlformats.org/drawingml/2006/main" xmlns:r="http://schemas.openxmlformats.org/officeDocument/2006/relationships" xmlns:p1510="http://schemas.microsoft.com/office/powerpoint/2015/10/main">
+  <p1510:revLst>
+    <p1510:client id="{05670DD9-9A0F-0049-2AEA-84CABAC00CF8}" v="6" dt="2026-01-31T05:36:01.739"/>
+  </p1510:revLst>
+</p1510:revInfo>
 </file>
 
 <file path=ppt/handoutMasters/handoutMaster1.xml><?xml version="1.0" encoding="utf-8"?>
@@ -6753,27 +6761,8 @@
                   </a:schemeClr>
                 </a:solidFill>
               </a:rPr>
-              <a:t>E2E with Diffusion Model </a:t>
-            </a:r>
-            <a:r>
-              <a:rPr lang="en-US" altLang="ko-KR" sz="3600" dirty="0" err="1">
-                <a:solidFill>
-                  <a:schemeClr val="tx1">
-                    <a:lumMod val="65000"/>
-                    <a:lumOff val="35000"/>
-                  </a:schemeClr>
-                </a:solidFill>
-              </a:rPr>
-              <a:t>Pallnning</a:t>
-            </a:r>
-            <a:endParaRPr lang="en-US" altLang="ko-KR" sz="3600" dirty="0">
-              <a:solidFill>
-                <a:schemeClr val="tx1">
-                  <a:lumMod val="65000"/>
-                  <a:lumOff val="35000"/>
-                </a:schemeClr>
-              </a:solidFill>
-            </a:endParaRPr>
+              <a:t>E2E with Diffusion Model Planning</a:t>
+            </a:r>
           </a:p>
         </p:txBody>
       </p:sp>

</xml_diff>